<commit_message>
added ppt of the project
</commit_message>
<xml_diff>
--- a/Capstone_project_retail_inventory.pptx
+++ b/Capstone_project_retail_inventory.pptx
@@ -171,7 +171,7 @@
               </a:defRPr>
             </a:pPr>
             <a:r>
-              <a:rPr sz="1200" b="0" i="0" u="none" strike="noStrike">
+              <a:rPr lang="en-US" sz="1200" b="0" i="0" u="none" strike="noStrike">
                 <a:solidFill>
                   <a:srgbClr val="172033"/>
                 </a:solidFill>
@@ -1866,7 +1866,7 @@
           </a:prstGeom>
           <a:extLst>
             <a:ext uri="{C572A759-6A51-4108-AA02-DFA0A04FC94B}">
-              <ma14:wrappingTextBoxFlag xmlns:ma14="http://schemas.microsoft.com/office/mac/drawingml/2011/main" xmlns="" val="0"/>
+              <ma14:wrappingTextBoxFlag xmlns="" xmlns:ma14="http://schemas.microsoft.com/office/mac/drawingml/2011/main" val="0"/>
             </a:ext>
           </a:extLst>
         </p:spPr>
@@ -1941,7 +1941,7 @@
           </a:prstGeom>
           <a:extLst>
             <a:ext uri="{C572A759-6A51-4108-AA02-DFA0A04FC94B}">
-              <ma14:wrappingTextBoxFlag xmlns:ma14="http://schemas.microsoft.com/office/mac/drawingml/2011/main" xmlns="" val="0"/>
+              <ma14:wrappingTextBoxFlag xmlns="" xmlns:ma14="http://schemas.microsoft.com/office/mac/drawingml/2011/main" val="0"/>
             </a:ext>
           </a:extLst>
         </p:spPr>
@@ -4096,7 +4096,7 @@
           </a:prstGeom>
           <a:extLst>
             <a:ext uri="{C572A759-6A51-4108-AA02-DFA0A04FC94B}">
-              <ma14:wrappingTextBoxFlag xmlns:ma14="http://schemas.microsoft.com/office/mac/drawingml/2011/main" xmlns="" val="0"/>
+              <ma14:wrappingTextBoxFlag xmlns="" xmlns:ma14="http://schemas.microsoft.com/office/mac/drawingml/2011/main" val="0"/>
             </a:ext>
           </a:extLst>
         </p:spPr>
@@ -5460,7 +5460,7 @@
           </a:prstGeom>
           <a:extLst>
             <a:ext uri="{C572A759-6A51-4108-AA02-DFA0A04FC94B}">
-              <ma14:wrappingTextBoxFlag xmlns:ma14="http://schemas.microsoft.com/office/mac/drawingml/2011/main" xmlns="" val="0"/>
+              <ma14:wrappingTextBoxFlag xmlns="" xmlns:ma14="http://schemas.microsoft.com/office/mac/drawingml/2011/main" val="0"/>
             </a:ext>
           </a:extLst>
         </p:spPr>
@@ -6774,7 +6774,7 @@
           </a:prstGeom>
           <a:extLst>
             <a:ext uri="{C572A759-6A51-4108-AA02-DFA0A04FC94B}">
-              <ma14:wrappingTextBoxFlag xmlns:ma14="http://schemas.microsoft.com/office/mac/drawingml/2011/main" xmlns="" val="0"/>
+              <ma14:wrappingTextBoxFlag xmlns="" xmlns:ma14="http://schemas.microsoft.com/office/mac/drawingml/2011/main" val="0"/>
             </a:ext>
           </a:extLst>
         </p:spPr>
@@ -7836,7 +7836,7 @@
           </a:prstGeom>
           <a:extLst>
             <a:ext uri="{C572A759-6A51-4108-AA02-DFA0A04FC94B}">
-              <ma14:wrappingTextBoxFlag xmlns:ma14="http://schemas.microsoft.com/office/mac/drawingml/2011/main" xmlns="" val="0"/>
+              <ma14:wrappingTextBoxFlag xmlns="" xmlns:ma14="http://schemas.microsoft.com/office/mac/drawingml/2011/main" val="0"/>
             </a:ext>
           </a:extLst>
         </p:spPr>
@@ -8629,7 +8629,7 @@
           </a:prstGeom>
           <a:extLst>
             <a:ext uri="{C572A759-6A51-4108-AA02-DFA0A04FC94B}">
-              <ma14:wrappingTextBoxFlag xmlns:ma14="http://schemas.microsoft.com/office/mac/drawingml/2011/main" xmlns="" val="0"/>
+              <ma14:wrappingTextBoxFlag xmlns="" xmlns:ma14="http://schemas.microsoft.com/office/mac/drawingml/2011/main" val="0"/>
             </a:ext>
           </a:extLst>
         </p:spPr>
@@ -9010,7 +9010,7 @@
         </p:nvGraphicFramePr>
         <p:xfrm>
           <a:off x="4754880" y="1371600"/>
-          <a:ext cx="3931920" cy="914400"/>
+          <a:ext cx="3931920" cy="2286000"/>
         </p:xfrm>
         <a:graphic>
           <a:graphicData uri="http://schemas.openxmlformats.org/drawingml/2006/table">
@@ -10214,7 +10214,7 @@
           </a:prstGeom>
           <a:extLst>
             <a:ext uri="{C572A759-6A51-4108-AA02-DFA0A04FC94B}">
-              <ma14:wrappingTextBoxFlag xmlns:ma14="http://schemas.microsoft.com/office/mac/drawingml/2011/main" xmlns="" val="0"/>
+              <ma14:wrappingTextBoxFlag xmlns="" xmlns:ma14="http://schemas.microsoft.com/office/mac/drawingml/2011/main" val="0"/>
             </a:ext>
           </a:extLst>
         </p:spPr>
@@ -10630,7 +10630,7 @@
                   <a:schemeClr val="tx1"/>
                 </a:solidFill>
               </a:rPr>
-              <a:t>Open http://localhost:8080; the API is at http://localhost:8000.</a:t>
+              <a:t>the API is at http://localhost:8000.</a:t>
             </a:r>
             <a:endParaRPr lang="en-US" sz="1200" dirty="0"/>
           </a:p>
@@ -11144,7 +11144,7 @@
           </a:prstGeom>
           <a:extLst>
             <a:ext uri="{C572A759-6A51-4108-AA02-DFA0A04FC94B}">
-              <ma14:wrappingTextBoxFlag xmlns:ma14="http://schemas.microsoft.com/office/mac/drawingml/2011/main" xmlns="" val="0"/>
+              <ma14:wrappingTextBoxFlag xmlns="" xmlns:ma14="http://schemas.microsoft.com/office/mac/drawingml/2011/main" val="0"/>
             </a:ext>
           </a:extLst>
         </p:spPr>

</xml_diff>